<commit_message>
Actualización de la presentación
Actualización de la presentación
</commit_message>
<xml_diff>
--- a/Presentacion/Movix_Presentacion_10_Ago_2026.pptx
+++ b/Presentacion/Movix_Presentacion_10_Ago_2026.pptx
@@ -127,7 +127,7 @@
   <pc:docChgLst>
     <pc:chgData name="Tomás Azofeifa" userId="a105d2f67a7af5de" providerId="LiveId" clId="{DFE61046-DF64-4E4A-8E75-50DE415B0D7F}"/>
     <pc:docChg chg="undo custSel modSld">
-      <pc:chgData name="Tomás Azofeifa" userId="a105d2f67a7af5de" providerId="LiveId" clId="{DFE61046-DF64-4E4A-8E75-50DE415B0D7F}" dt="2026-08-10T00:55:53.771" v="89" actId="1036"/>
+      <pc:chgData name="Tomás Azofeifa" userId="a105d2f67a7af5de" providerId="LiveId" clId="{DFE61046-DF64-4E4A-8E75-50DE415B0D7F}" dt="2026-08-10T01:33:21.628" v="97" actId="14100"/>
       <pc:docMkLst>
         <pc:docMk/>
       </pc:docMkLst>
@@ -179,11 +179,19 @@
         </pc:picChg>
       </pc:sldChg>
       <pc:sldChg chg="delSp modSp mod">
-        <pc:chgData name="Tomás Azofeifa" userId="a105d2f67a7af5de" providerId="LiveId" clId="{DFE61046-DF64-4E4A-8E75-50DE415B0D7F}" dt="2026-08-10T00:49:47.047" v="41" actId="478"/>
+        <pc:chgData name="Tomás Azofeifa" userId="a105d2f67a7af5de" providerId="LiveId" clId="{DFE61046-DF64-4E4A-8E75-50DE415B0D7F}" dt="2026-08-10T01:32:27.978" v="92" actId="20577"/>
         <pc:sldMkLst>
           <pc:docMk/>
           <pc:sldMk cId="0" sldId="257"/>
         </pc:sldMkLst>
+        <pc:spChg chg="mod">
+          <ac:chgData name="Tomás Azofeifa" userId="a105d2f67a7af5de" providerId="LiveId" clId="{DFE61046-DF64-4E4A-8E75-50DE415B0D7F}" dt="2026-08-10T01:32:27.978" v="92" actId="20577"/>
+          <ac:spMkLst>
+            <pc:docMk/>
+            <pc:sldMk cId="0" sldId="257"/>
+            <ac:spMk id="2" creationId="{00000000-0000-0000-0000-000000000000}"/>
+          </ac:spMkLst>
+        </pc:spChg>
         <pc:spChg chg="mod">
           <ac:chgData name="Tomás Azofeifa" userId="a105d2f67a7af5de" providerId="LiveId" clId="{DFE61046-DF64-4E4A-8E75-50DE415B0D7F}" dt="2026-08-10T00:49:33.224" v="40" actId="207"/>
           <ac:spMkLst>
@@ -201,12 +209,20 @@
           </ac:spMkLst>
         </pc:spChg>
       </pc:sldChg>
-      <pc:sldChg chg="delSp mod">
-        <pc:chgData name="Tomás Azofeifa" userId="a105d2f67a7af5de" providerId="LiveId" clId="{DFE61046-DF64-4E4A-8E75-50DE415B0D7F}" dt="2026-08-10T00:53:18.266" v="65" actId="478"/>
+      <pc:sldChg chg="delSp modSp mod">
+        <pc:chgData name="Tomás Azofeifa" userId="a105d2f67a7af5de" providerId="LiveId" clId="{DFE61046-DF64-4E4A-8E75-50DE415B0D7F}" dt="2026-08-10T01:32:33.803" v="94" actId="27636"/>
         <pc:sldMkLst>
           <pc:docMk/>
           <pc:sldMk cId="0" sldId="258"/>
         </pc:sldMkLst>
+        <pc:spChg chg="mod">
+          <ac:chgData name="Tomás Azofeifa" userId="a105d2f67a7af5de" providerId="LiveId" clId="{DFE61046-DF64-4E4A-8E75-50DE415B0D7F}" dt="2026-08-10T01:32:33.803" v="94" actId="27636"/>
+          <ac:spMkLst>
+            <pc:docMk/>
+            <pc:sldMk cId="0" sldId="258"/>
+            <ac:spMk id="2" creationId="{00000000-0000-0000-0000-000000000000}"/>
+          </ac:spMkLst>
+        </pc:spChg>
         <pc:spChg chg="del">
           <ac:chgData name="Tomás Azofeifa" userId="a105d2f67a7af5de" providerId="LiveId" clId="{DFE61046-DF64-4E4A-8E75-50DE415B0D7F}" dt="2026-08-10T00:53:18.266" v="65" actId="478"/>
           <ac:spMkLst>
@@ -216,12 +232,28 @@
           </ac:spMkLst>
         </pc:spChg>
       </pc:sldChg>
-      <pc:sldChg chg="delSp mod">
-        <pc:chgData name="Tomás Azofeifa" userId="a105d2f67a7af5de" providerId="LiveId" clId="{DFE61046-DF64-4E4A-8E75-50DE415B0D7F}" dt="2026-08-10T00:53:14.671" v="64" actId="478"/>
+      <pc:sldChg chg="delSp modSp mod">
+        <pc:chgData name="Tomás Azofeifa" userId="a105d2f67a7af5de" providerId="LiveId" clId="{DFE61046-DF64-4E4A-8E75-50DE415B0D7F}" dt="2026-08-10T01:32:43.475" v="96" actId="14100"/>
         <pc:sldMkLst>
           <pc:docMk/>
           <pc:sldMk cId="0" sldId="259"/>
         </pc:sldMkLst>
+        <pc:spChg chg="mod">
+          <ac:chgData name="Tomás Azofeifa" userId="a105d2f67a7af5de" providerId="LiveId" clId="{DFE61046-DF64-4E4A-8E75-50DE415B0D7F}" dt="2026-08-10T01:32:43.475" v="96" actId="14100"/>
+          <ac:spMkLst>
+            <pc:docMk/>
+            <pc:sldMk cId="0" sldId="259"/>
+            <ac:spMk id="3" creationId="{00000000-0000-0000-0000-000000000000}"/>
+          </ac:spMkLst>
+        </pc:spChg>
+        <pc:spChg chg="mod">
+          <ac:chgData name="Tomás Azofeifa" userId="a105d2f67a7af5de" providerId="LiveId" clId="{DFE61046-DF64-4E4A-8E75-50DE415B0D7F}" dt="2026-08-10T01:32:38.851" v="95" actId="1076"/>
+          <ac:spMkLst>
+            <pc:docMk/>
+            <pc:sldMk cId="0" sldId="259"/>
+            <ac:spMk id="4" creationId="{00000000-0000-0000-0000-000000000000}"/>
+          </ac:spMkLst>
+        </pc:spChg>
         <pc:spChg chg="del">
           <ac:chgData name="Tomás Azofeifa" userId="a105d2f67a7af5de" providerId="LiveId" clId="{DFE61046-DF64-4E4A-8E75-50DE415B0D7F}" dt="2026-08-10T00:53:14.671" v="64" actId="478"/>
           <ac:spMkLst>
@@ -331,12 +363,20 @@
           </ac:spMkLst>
         </pc:spChg>
       </pc:sldChg>
-      <pc:sldChg chg="delSp mod">
-        <pc:chgData name="Tomás Azofeifa" userId="a105d2f67a7af5de" providerId="LiveId" clId="{DFE61046-DF64-4E4A-8E75-50DE415B0D7F}" dt="2026-08-10T00:52:50.989" v="59" actId="478"/>
+      <pc:sldChg chg="delSp modSp mod">
+        <pc:chgData name="Tomás Azofeifa" userId="a105d2f67a7af5de" providerId="LiveId" clId="{DFE61046-DF64-4E4A-8E75-50DE415B0D7F}" dt="2026-08-10T01:33:21.628" v="97" actId="14100"/>
         <pc:sldMkLst>
           <pc:docMk/>
           <pc:sldMk cId="0" sldId="264"/>
         </pc:sldMkLst>
+        <pc:spChg chg="mod">
+          <ac:chgData name="Tomás Azofeifa" userId="a105d2f67a7af5de" providerId="LiveId" clId="{DFE61046-DF64-4E4A-8E75-50DE415B0D7F}" dt="2026-08-10T01:33:21.628" v="97" actId="14100"/>
+          <ac:spMkLst>
+            <pc:docMk/>
+            <pc:sldMk cId="0" sldId="264"/>
+            <ac:spMk id="2" creationId="{00000000-0000-0000-0000-000000000000}"/>
+          </ac:spMkLst>
+        </pc:spChg>
         <pc:spChg chg="del">
           <ac:chgData name="Tomás Azofeifa" userId="a105d2f67a7af5de" providerId="LiveId" clId="{DFE61046-DF64-4E4A-8E75-50DE415B0D7F}" dt="2026-08-10T00:52:50.989" v="59" actId="478"/>
           <ac:spMkLst>
@@ -1660,7 +1700,7 @@
           </a:prstGeom>
           <a:extLst>
             <a:ext uri="{C572A759-6A51-4108-AA02-DFA0A04FC94B}">
-              <ma14:wrappingTextBoxFlag xmlns:ma14="http://schemas.microsoft.com/office/mac/drawingml/2011/main" xmlns="" val="0"/>
+              <ma14:wrappingTextBoxFlag xmlns="" xmlns:ma14="http://schemas.microsoft.com/office/mac/drawingml/2011/main" val="0"/>
             </a:ext>
           </a:extLst>
         </p:spPr>
@@ -1735,7 +1775,7 @@
           </a:prstGeom>
           <a:extLst>
             <a:ext uri="{C572A759-6A51-4108-AA02-DFA0A04FC94B}">
-              <ma14:wrappingTextBoxFlag xmlns:ma14="http://schemas.microsoft.com/office/mac/drawingml/2011/main" xmlns="" val="0"/>
+              <ma14:wrappingTextBoxFlag xmlns="" xmlns:ma14="http://schemas.microsoft.com/office/mac/drawingml/2011/main" val="0"/>
             </a:ext>
           </a:extLst>
         </p:spPr>
@@ -4422,7 +4462,7 @@
           </a:prstGeom>
           <a:extLst>
             <a:ext uri="{C572A759-6A51-4108-AA02-DFA0A04FC94B}">
-              <ma14:wrappingTextBoxFlag xmlns:ma14="http://schemas.microsoft.com/office/mac/drawingml/2011/main" xmlns="" val="0"/>
+              <ma14:wrappingTextBoxFlag xmlns="" xmlns:ma14="http://schemas.microsoft.com/office/mac/drawingml/2011/main" val="0"/>
             </a:ext>
           </a:extLst>
         </p:spPr>
@@ -5416,7 +5456,7 @@
                 <a:ea typeface="Aptos" pitchFamily="34" charset="-122"/>
                 <a:cs typeface="Aptos" pitchFamily="34" charset="-120"/>
               </a:rPr>
-              <a:t>01 · CONTEXTO Y ALCANCE</a:t>
+              <a:t>01 · CONTEXTO</a:t>
             </a:r>
             <a:endParaRPr lang="en-US" sz="900" dirty="0"/>
           </a:p>
@@ -7323,7 +7363,7 @@
           </a:prstGeom>
           <a:extLst>
             <a:ext uri="{C572A759-6A51-4108-AA02-DFA0A04FC94B}">
-              <ma14:wrappingTextBoxFlag xmlns:ma14="http://schemas.microsoft.com/office/mac/drawingml/2011/main" xmlns="" val="0"/>
+              <ma14:wrappingTextBoxFlag xmlns="" xmlns:ma14="http://schemas.microsoft.com/office/mac/drawingml/2011/main" val="0"/>
             </a:ext>
           </a:extLst>
         </p:spPr>
@@ -7382,7 +7422,7 @@
         <p:spPr>
           <a:xfrm>
             <a:off x="502920" y="292608"/>
-            <a:ext cx="3017520" cy="201168"/>
+            <a:ext cx="4142232" cy="128016"/>
           </a:xfrm>
           <a:prstGeom prst="rect">
             <a:avLst/>
@@ -7392,7 +7432,7 @@
         </p:spPr>
         <p:txBody>
           <a:bodyPr wrap="square" lIns="0" tIns="0" rIns="0" bIns="0" rtlCol="0" anchor="ctr">
-            <a:normAutofit/>
+            <a:normAutofit lnSpcReduction="10000"/>
           </a:bodyPr>
           <a:lstStyle/>
           <a:p>
@@ -9282,7 +9322,7 @@
           </a:prstGeom>
           <a:extLst>
             <a:ext uri="{C572A759-6A51-4108-AA02-DFA0A04FC94B}">
-              <ma14:wrappingTextBoxFlag xmlns:ma14="http://schemas.microsoft.com/office/mac/drawingml/2011/main" xmlns="" val="0"/>
+              <ma14:wrappingTextBoxFlag xmlns="" xmlns:ma14="http://schemas.microsoft.com/office/mac/drawingml/2011/main" val="0"/>
             </a:ext>
           </a:extLst>
         </p:spPr>
@@ -9382,7 +9422,7 @@
         <p:spPr>
           <a:xfrm>
             <a:off x="502920" y="530352"/>
-            <a:ext cx="11064240" cy="493776"/>
+            <a:ext cx="11320272" cy="493776"/>
           </a:xfrm>
           <a:prstGeom prst="rect">
             <a:avLst/>
@@ -9422,7 +9462,7 @@
         </p:nvSpPr>
         <p:spPr>
           <a:xfrm>
-            <a:off x="502920" y="1024128"/>
+            <a:off x="502920" y="1175004"/>
             <a:ext cx="10972800" cy="384048"/>
           </a:xfrm>
           <a:prstGeom prst="rect">
@@ -11030,7 +11070,7 @@
           </a:prstGeom>
           <a:extLst>
             <a:ext uri="{C572A759-6A51-4108-AA02-DFA0A04FC94B}">
-              <ma14:wrappingTextBoxFlag xmlns:ma14="http://schemas.microsoft.com/office/mac/drawingml/2011/main" xmlns="" val="0"/>
+              <ma14:wrappingTextBoxFlag xmlns="" xmlns:ma14="http://schemas.microsoft.com/office/mac/drawingml/2011/main" val="0"/>
             </a:ext>
           </a:extLst>
         </p:spPr>
@@ -12222,7 +12262,7 @@
           </a:prstGeom>
           <a:extLst>
             <a:ext uri="{C572A759-6A51-4108-AA02-DFA0A04FC94B}">
-              <ma14:wrappingTextBoxFlag xmlns:ma14="http://schemas.microsoft.com/office/mac/drawingml/2011/main" xmlns="" val="0"/>
+              <ma14:wrappingTextBoxFlag xmlns="" xmlns:ma14="http://schemas.microsoft.com/office/mac/drawingml/2011/main" val="0"/>
             </a:ext>
           </a:extLst>
         </p:spPr>
@@ -13227,7 +13267,7 @@
           </a:prstGeom>
           <a:extLst>
             <a:ext uri="{C572A759-6A51-4108-AA02-DFA0A04FC94B}">
-              <ma14:wrappingTextBoxFlag xmlns:ma14="http://schemas.microsoft.com/office/mac/drawingml/2011/main" xmlns="" val="0"/>
+              <ma14:wrappingTextBoxFlag xmlns="" xmlns:ma14="http://schemas.microsoft.com/office/mac/drawingml/2011/main" val="0"/>
             </a:ext>
           </a:extLst>
         </p:spPr>
@@ -15054,7 +15094,7 @@
           </a:prstGeom>
           <a:extLst>
             <a:ext uri="{C572A759-6A51-4108-AA02-DFA0A04FC94B}">
-              <ma14:wrappingTextBoxFlag xmlns:ma14="http://schemas.microsoft.com/office/mac/drawingml/2011/main" xmlns="" val="0"/>
+              <ma14:wrappingTextBoxFlag xmlns="" xmlns:ma14="http://schemas.microsoft.com/office/mac/drawingml/2011/main" val="0"/>
             </a:ext>
           </a:extLst>
         </p:spPr>
@@ -17120,7 +17160,7 @@
           </a:prstGeom>
           <a:extLst>
             <a:ext uri="{C572A759-6A51-4108-AA02-DFA0A04FC94B}">
-              <ma14:wrappingTextBoxFlag xmlns:ma14="http://schemas.microsoft.com/office/mac/drawingml/2011/main" xmlns="" val="0"/>
+              <ma14:wrappingTextBoxFlag xmlns="" xmlns:ma14="http://schemas.microsoft.com/office/mac/drawingml/2011/main" val="0"/>
             </a:ext>
           </a:extLst>
         </p:spPr>
@@ -17178,8 +17218,8 @@
         </p:nvSpPr>
         <p:spPr>
           <a:xfrm>
-            <a:off x="502920" y="292608"/>
-            <a:ext cx="3017520" cy="201168"/>
+            <a:off x="502919" y="292608"/>
+            <a:ext cx="4022427" cy="137160"/>
           </a:xfrm>
           <a:prstGeom prst="rect">
             <a:avLst/>
@@ -18093,7 +18133,7 @@
           </a:prstGeom>
           <a:extLst>
             <a:ext uri="{C572A759-6A51-4108-AA02-DFA0A04FC94B}">
-              <ma14:wrappingTextBoxFlag xmlns:ma14="http://schemas.microsoft.com/office/mac/drawingml/2011/main" xmlns="" val="0"/>
+              <ma14:wrappingTextBoxFlag xmlns="" xmlns:ma14="http://schemas.microsoft.com/office/mac/drawingml/2011/main" val="0"/>
             </a:ext>
           </a:extLst>
         </p:spPr>

</xml_diff>